<commit_message>
Add RW prediction-error analysis scripts and load_unit_info utility
- analysis/fr_pe_correlation.py and fr_pe_significance.py: new scripts
  computing firing-rate vs RW PE correlations and region-level significance
- utils.py: add load_unit_info() to parse structured per-neuron metadata
  from STMtx.mat infoCell (region/electrode/unit_id/unit_type)
- results/rw/: significance summary PNGs for reward-to-end window
- presentation/Prototype.pptx: updated slides

Co-Authored-By: Claude Sonnet 4.6 <noreply@anthropic.com>
Claude-Session: https://claude.ai/code/session_01JLDY2236hd4pe4y5zJcgyQ
</commit_message>
<xml_diff>
--- a/presentation/Prototype.pptx
+++ b/presentation/Prototype.pptx
@@ -5,7 +5,7 @@
     <p:sldMasterId id="2147483648" r:id="rId1"/>
   </p:sldMasterIdLst>
   <p:handoutMasterIdLst>
-    <p:handoutMasterId r:id="rId28"/>
+    <p:handoutMasterId r:id="rId31"/>
   </p:handoutMasterIdLst>
   <p:sldIdLst>
     <p:sldId id="256" r:id="rId2"/>
@@ -27,13 +27,16 @@
     <p:sldId id="279" r:id="rId18"/>
     <p:sldId id="278" r:id="rId19"/>
     <p:sldId id="276" r:id="rId20"/>
-    <p:sldId id="281" r:id="rId21"/>
-    <p:sldId id="263" r:id="rId22"/>
+    <p:sldId id="263" r:id="rId21"/>
+    <p:sldId id="283" r:id="rId22"/>
     <p:sldId id="280" r:id="rId23"/>
     <p:sldId id="282" r:id="rId24"/>
     <p:sldId id="265" r:id="rId25"/>
     <p:sldId id="266" r:id="rId26"/>
     <p:sldId id="267" r:id="rId27"/>
+    <p:sldId id="284" r:id="rId28"/>
+    <p:sldId id="285" r:id="rId29"/>
+    <p:sldId id="286" r:id="rId30"/>
   </p:sldIdLst>
   <p:sldSz cx="12192000" cy="6858000"/>
   <p:notesSz cx="6858000" cy="9144000"/>
@@ -11190,100 +11193,17 @@
                   <a:pPr algn="ctr"/>
                   <a14:m>
                     <m:oMath xmlns:m="http://schemas.openxmlformats.org/officeDocument/2006/math">
-                      <m:sSub>
-                        <m:sSubPr>
-                          <m:ctrlPr>
-                            <a:rPr lang="de-DE" sz="2400" i="1">
-                              <a:solidFill>
-                                <a:schemeClr val="tx1"/>
-                              </a:solidFill>
-                              <a:latin typeface="Cambria Math" panose="02040503050406030204" pitchFamily="18" charset="0"/>
-                              <a:ea typeface="Cambria Math" panose="02040503050406030204" pitchFamily="18" charset="0"/>
-                            </a:rPr>
-                          </m:ctrlPr>
-                        </m:sSubPr>
-                        <m:e>
-                          <m:r>
-                            <a:rPr lang="de-DE" sz="2400" i="1">
-                              <a:solidFill>
-                                <a:schemeClr val="tx1"/>
-                              </a:solidFill>
-                              <a:latin typeface="Cambria Math" panose="02040503050406030204" pitchFamily="18" charset="0"/>
-                              <a:ea typeface="Cambria Math" panose="02040503050406030204" pitchFamily="18" charset="0"/>
-                            </a:rPr>
-                            <m:t>𝑐</m:t>
-                          </m:r>
-                        </m:e>
-                        <m:sub>
-                          <m:r>
-                            <a:rPr lang="de-DE" sz="2400" i="1">
-                              <a:solidFill>
-                                <a:schemeClr val="tx1"/>
-                              </a:solidFill>
-                              <a:latin typeface="Cambria Math" panose="02040503050406030204" pitchFamily="18" charset="0"/>
-                              <a:ea typeface="Cambria Math" panose="02040503050406030204" pitchFamily="18" charset="0"/>
-                            </a:rPr>
-                            <m:t>𝑡</m:t>
-                          </m:r>
-                          <m:r>
-                            <a:rPr lang="de-DE" sz="2400" i="1">
-                              <a:solidFill>
-                                <a:schemeClr val="tx1"/>
-                              </a:solidFill>
-                              <a:latin typeface="Cambria Math" panose="02040503050406030204" pitchFamily="18" charset="0"/>
-                              <a:ea typeface="Cambria Math" panose="02040503050406030204" pitchFamily="18" charset="0"/>
-                            </a:rPr>
-                            <m:t>−1</m:t>
-                          </m:r>
-                        </m:sub>
-                      </m:sSub>
                       <m:r>
                         <a:rPr lang="de-DE" sz="2400" i="1">
                           <a:solidFill>
                             <a:schemeClr val="tx1"/>
                           </a:solidFill>
                           <a:latin typeface="Cambria Math" panose="02040503050406030204" pitchFamily="18" charset="0"/>
-                          <a:ea typeface="Cambria Math" panose="02040503050406030204" pitchFamily="18" charset="0"/>
                         </a:rPr>
-                        <m:t>= ±1=</m:t>
-                      </m:r>
-                    </m:oMath>
-                  </a14:m>
-                  <a:r>
-                    <a:rPr lang="en-GB" sz="2400" i="1" dirty="0">
-                      <a:solidFill>
-                        <a:schemeClr val="tx1"/>
-                      </a:solidFill>
-                      <a:latin typeface="Cambria Math" panose="02040503050406030204" pitchFamily="18" charset="0"/>
-                      <a:ea typeface="Cambria Math" panose="02040503050406030204" pitchFamily="18" charset="0"/>
-                    </a:rPr>
-                    <a:t> </a:t>
-                  </a:r>
-                  <a:r>
-                    <a:rPr lang="en-GB" sz="2400" dirty="0">
-                      <a:solidFill>
-                        <a:schemeClr val="tx1"/>
-                      </a:solidFill>
-                      <a:latin typeface="Bahnschrift" panose="020B0502040204020203" pitchFamily="34" charset="0"/>
-                    </a:rPr>
-                    <a:t>previous choice; </a:t>
-                  </a:r>
-                  <a14:m>
-                    <m:oMath xmlns:m="http://schemas.openxmlformats.org/officeDocument/2006/math">
-                      <m:r>
-                        <m:rPr>
-                          <m:sty m:val="p"/>
-                        </m:rPr>
-                        <a:rPr lang="de-DE" sz="2400">
-                          <a:solidFill>
-                            <a:schemeClr val="tx1"/>
-                          </a:solidFill>
-                          <a:latin typeface="Bahnschrift" panose="020B0502040204020203" pitchFamily="34" charset="0"/>
-                        </a:rPr>
-                        <m:t>κ</m:t>
+                        <m:t>𝛽</m:t>
                       </m:r>
                       <m:r>
-                        <a:rPr lang="de-DE" sz="2400" b="0" i="0" smtClean="0">
+                        <a:rPr lang="de-DE" sz="2400" i="1">
                           <a:solidFill>
                             <a:schemeClr val="tx1"/>
                           </a:solidFill>
@@ -11294,53 +11214,22 @@
                     </m:oMath>
                   </a14:m>
                   <a:r>
-                    <a:rPr lang="en-GB" sz="2400" dirty="0">
+                    <a:rPr lang="de-DE" sz="2400" dirty="0">
+                      <a:solidFill>
+                        <a:schemeClr val="tx1"/>
+                      </a:solidFill>
+                      <a:ea typeface="Cambria Math" panose="02040503050406030204" pitchFamily="18" charset="0"/>
+                    </a:rPr>
+                    <a:t> </a:t>
+                  </a:r>
+                  <a:r>
+                    <a:rPr lang="de-DE" sz="2400" dirty="0" smtClean="0">
                       <a:solidFill>
                         <a:schemeClr val="tx1"/>
                       </a:solidFill>
                       <a:latin typeface="Bahnschrift" panose="020B0502040204020203" pitchFamily="34" charset="0"/>
                     </a:rPr>
-                    <a:t> weights </a:t>
-                  </a:r>
-                  <a:r>
-                    <a:rPr lang="en-GB" sz="2400" dirty="0" smtClean="0">
-                      <a:solidFill>
-                        <a:schemeClr val="tx1"/>
-                      </a:solidFill>
-                      <a:latin typeface="Bahnschrift" panose="020B0502040204020203" pitchFamily="34" charset="0"/>
-                    </a:rPr>
-                    <a:t>preservation; </a:t>
-                  </a:r>
-                  <a14:m>
-                    <m:oMath xmlns:m="http://schemas.openxmlformats.org/officeDocument/2006/math">
-                      <m:r>
-                        <a:rPr lang="de-DE" sz="2400" b="0" i="1" smtClean="0">
-                          <a:solidFill>
-                            <a:schemeClr val="tx1"/>
-                          </a:solidFill>
-                          <a:latin typeface="Cambria Math" panose="02040503050406030204" pitchFamily="18" charset="0"/>
-                        </a:rPr>
-                        <m:t>𝑏</m:t>
-                      </m:r>
-                      <m:r>
-                        <a:rPr lang="de-DE" sz="2400" b="0" i="1" smtClean="0">
-                          <a:solidFill>
-                            <a:schemeClr val="tx1"/>
-                          </a:solidFill>
-                          <a:latin typeface="Cambria Math" panose="02040503050406030204" pitchFamily="18" charset="0"/>
-                        </a:rPr>
-                        <m:t>=</m:t>
-                      </m:r>
-                    </m:oMath>
-                  </a14:m>
-                  <a:r>
-                    <a:rPr lang="en-GB" sz="2400" dirty="0" smtClean="0">
-                      <a:solidFill>
-                        <a:schemeClr val="tx1"/>
-                      </a:solidFill>
-                      <a:latin typeface="Bahnschrift" panose="020B0502040204020203" pitchFamily="34" charset="0"/>
-                    </a:rPr>
-                    <a:t> overall bias </a:t>
+                    <a:t>temperature</a:t>
                   </a:r>
                   <a:endParaRPr lang="en-GB" sz="2400" dirty="0">
                     <a:solidFill>
@@ -11411,8 +11300,8 @@
               </p:nvSpPr>
               <p:spPr>
                 <a:xfrm>
-                  <a:off x="3297221" y="4543897"/>
-                  <a:ext cx="5597558" cy="430887"/>
+                  <a:off x="4245525" y="4569568"/>
+                  <a:ext cx="3700949" cy="430887"/>
                 </a:xfrm>
                 <a:prstGeom prst="rect">
                   <a:avLst/>
@@ -11533,61 +11422,6 @@
                           <a:rPr lang="de-DE" sz="2800" i="1">
                             <a:latin typeface="Cambria Math" panose="02040503050406030204" pitchFamily="18" charset="0"/>
                           </a:rPr>
-                          <m:t>+</m:t>
-                        </m:r>
-                        <m:r>
-                          <a:rPr lang="de-DE" sz="2800" i="1">
-                            <a:latin typeface="Cambria Math" panose="02040503050406030204" pitchFamily="18" charset="0"/>
-                          </a:rPr>
-                          <m:t>𝜅</m:t>
-                        </m:r>
-                        <m:sSub>
-                          <m:sSubPr>
-                            <m:ctrlPr>
-                              <a:rPr lang="de-DE" sz="2800" i="1">
-                                <a:latin typeface="Cambria Math" panose="02040503050406030204" pitchFamily="18" charset="0"/>
-                              </a:rPr>
-                            </m:ctrlPr>
-                          </m:sSubPr>
-                          <m:e>
-                            <m:r>
-                              <a:rPr lang="de-DE" sz="2800" i="1">
-                                <a:latin typeface="Cambria Math" panose="02040503050406030204" pitchFamily="18" charset="0"/>
-                              </a:rPr>
-                              <m:t>𝑐</m:t>
-                            </m:r>
-                          </m:e>
-                          <m:sub>
-                            <m:r>
-                              <a:rPr lang="de-DE" sz="2800" i="1">
-                                <a:latin typeface="Cambria Math" panose="02040503050406030204" pitchFamily="18" charset="0"/>
-                              </a:rPr>
-                              <m:t>𝑡</m:t>
-                            </m:r>
-                            <m:r>
-                              <a:rPr lang="de-DE" sz="2800" i="1">
-                                <a:latin typeface="Cambria Math" panose="02040503050406030204" pitchFamily="18" charset="0"/>
-                              </a:rPr>
-                              <m:t>−1</m:t>
-                            </m:r>
-                          </m:sub>
-                        </m:sSub>
-                        <m:r>
-                          <a:rPr lang="de-DE" sz="2800" i="1">
-                            <a:latin typeface="Cambria Math" panose="02040503050406030204" pitchFamily="18" charset="0"/>
-                          </a:rPr>
-                          <m:t>+</m:t>
-                        </m:r>
-                        <m:r>
-                          <a:rPr lang="de-DE" sz="2800" i="1">
-                            <a:latin typeface="Cambria Math" panose="02040503050406030204" pitchFamily="18" charset="0"/>
-                          </a:rPr>
-                          <m:t>𝑏</m:t>
-                        </m:r>
-                        <m:r>
-                          <a:rPr lang="de-DE" sz="2800" i="1">
-                            <a:latin typeface="Cambria Math" panose="02040503050406030204" pitchFamily="18" charset="0"/>
-                          </a:rPr>
                           <m:t>)</m:t>
                         </m:r>
                       </m:oMath>
@@ -11611,8 +11445,8 @@
               </p:nvSpPr>
               <p:spPr>
                 <a:xfrm>
-                  <a:off x="3297221" y="4543897"/>
-                  <a:ext cx="5597558" cy="430887"/>
+                  <a:off x="4245525" y="4569568"/>
+                  <a:ext cx="3700949" cy="430887"/>
                 </a:xfrm>
                 <a:prstGeom prst="rect">
                   <a:avLst/>
@@ -11640,6 +11474,79 @@
           </mc:Fallback>
         </mc:AlternateContent>
       </p:grpSp>
+      <p:sp>
+        <p:nvSpPr>
+          <p:cNvPr id="10" name="TextBox 9"/>
+          <p:cNvSpPr txBox="1"/>
+          <p:nvPr/>
+        </p:nvSpPr>
+        <p:spPr>
+          <a:xfrm>
+            <a:off x="927100" y="1886858"/>
+            <a:ext cx="10337800" cy="3108543"/>
+          </a:xfrm>
+          <a:prstGeom prst="rect">
+            <a:avLst/>
+          </a:prstGeom>
+          <a:noFill/>
+        </p:spPr>
+        <p:txBody>
+          <a:bodyPr wrap="square" rtlCol="0">
+            <a:spAutoFit/>
+          </a:bodyPr>
+          <a:lstStyle/>
+          <a:p>
+            <a:r>
+              <a:rPr lang="de-DE" sz="2800" dirty="0">
+                <a:latin typeface="Bahnschrift" panose="020B0502040204020203" pitchFamily="34" charset="0"/>
+              </a:rPr>
+              <a:t>For each side</a:t>
+            </a:r>
+            <a:r>
+              <a:rPr lang="de-DE" sz="2800" dirty="0" smtClean="0">
+                <a:latin typeface="Bahnschrift" panose="020B0502040204020203" pitchFamily="34" charset="0"/>
+              </a:rPr>
+              <a:t>:</a:t>
+            </a:r>
+          </a:p>
+          <a:p>
+            <a:endParaRPr lang="de-DE" sz="2800" dirty="0">
+              <a:latin typeface="Bahnschrift" panose="020B0502040204020203" pitchFamily="34" charset="0"/>
+            </a:endParaRPr>
+          </a:p>
+          <a:p>
+            <a:endParaRPr lang="de-DE" sz="2800" dirty="0" smtClean="0">
+              <a:latin typeface="Bahnschrift" panose="020B0502040204020203" pitchFamily="34" charset="0"/>
+            </a:endParaRPr>
+          </a:p>
+          <a:p>
+            <a:endParaRPr lang="de-DE" sz="2800" dirty="0">
+              <a:latin typeface="Bahnschrift" panose="020B0502040204020203" pitchFamily="34" charset="0"/>
+            </a:endParaRPr>
+          </a:p>
+          <a:p>
+            <a:endParaRPr lang="de-DE" sz="2800" dirty="0" smtClean="0">
+              <a:latin typeface="Bahnschrift" panose="020B0502040204020203" pitchFamily="34" charset="0"/>
+            </a:endParaRPr>
+          </a:p>
+          <a:p>
+            <a:r>
+              <a:rPr lang="de-DE" sz="2800" dirty="0" smtClean="0">
+                <a:latin typeface="Bahnschrift" panose="020B0502040204020203" pitchFamily="34" charset="0"/>
+              </a:rPr>
+              <a:t>Their difference is used to calculate the probability to gamble:</a:t>
+            </a:r>
+            <a:endParaRPr lang="de-DE" sz="2800" dirty="0">
+              <a:latin typeface="Bahnschrift" panose="020B0502040204020203" pitchFamily="34" charset="0"/>
+            </a:endParaRPr>
+          </a:p>
+          <a:p>
+            <a:endParaRPr lang="en-GB" sz="2800" dirty="0">
+              <a:latin typeface="Bahnschrift" panose="020B0502040204020203" pitchFamily="34" charset="0"/>
+            </a:endParaRPr>
+          </a:p>
+        </p:txBody>
+      </p:sp>
       <mc:AlternateContent xmlns:mc="http://schemas.openxmlformats.org/markup-compatibility/2006">
         <mc:Choice xmlns:a14="http://schemas.microsoft.com/office/drawing/2010/main" Requires="a14">
           <p:sp>
@@ -11650,8 +11557,8 @@
             </p:nvSpPr>
             <p:spPr>
               <a:xfrm>
-                <a:off x="12607034" y="1392425"/>
-                <a:ext cx="4106573" cy="2871189"/>
+                <a:off x="7946474" y="4545597"/>
+                <a:ext cx="2507295" cy="1502310"/>
               </a:xfrm>
               <a:prstGeom prst="roundRect">
                 <a:avLst>
@@ -11703,7 +11610,7 @@
                           </a:solidFill>
                           <a:latin typeface="Cambria Math" panose="02040503050406030204" pitchFamily="18" charset="0"/>
                         </a:rPr>
-                        <m:t>1</m:t>
+                        <m:t>=1</m:t>
                       </m:r>
                       <m:f>
                         <m:fPr>
@@ -11824,85 +11731,6 @@
                                 </m:sub>
                               </m:sSub>
                               <m:r>
-                                <a:rPr lang="de-DE" sz="2400" i="1">
-                                  <a:solidFill>
-                                    <a:schemeClr val="tx1"/>
-                                  </a:solidFill>
-                                  <a:latin typeface="Cambria Math" panose="02040503050406030204" pitchFamily="18" charset="0"/>
-                                </a:rPr>
-                                <m:t>+</m:t>
-                              </m:r>
-                              <m:r>
-                                <a:rPr lang="de-DE" sz="2400" i="1">
-                                  <a:solidFill>
-                                    <a:schemeClr val="tx1"/>
-                                  </a:solidFill>
-                                  <a:latin typeface="Cambria Math" panose="02040503050406030204" pitchFamily="18" charset="0"/>
-                                </a:rPr>
-                                <m:t>𝜅</m:t>
-                              </m:r>
-                              <m:sSub>
-                                <m:sSubPr>
-                                  <m:ctrlPr>
-                                    <a:rPr lang="de-DE" sz="2400" i="1">
-                                      <a:solidFill>
-                                        <a:schemeClr val="tx1"/>
-                                      </a:solidFill>
-                                      <a:latin typeface="Cambria Math" panose="02040503050406030204" pitchFamily="18" charset="0"/>
-                                    </a:rPr>
-                                  </m:ctrlPr>
-                                </m:sSubPr>
-                                <m:e>
-                                  <m:r>
-                                    <a:rPr lang="de-DE" sz="2400" i="1">
-                                      <a:solidFill>
-                                        <a:schemeClr val="tx1"/>
-                                      </a:solidFill>
-                                      <a:latin typeface="Cambria Math" panose="02040503050406030204" pitchFamily="18" charset="0"/>
-                                    </a:rPr>
-                                    <m:t>𝑐</m:t>
-                                  </m:r>
-                                </m:e>
-                                <m:sub>
-                                  <m:r>
-                                    <a:rPr lang="de-DE" sz="2400" i="1">
-                                      <a:solidFill>
-                                        <a:schemeClr val="tx1"/>
-                                      </a:solidFill>
-                                      <a:latin typeface="Cambria Math" panose="02040503050406030204" pitchFamily="18" charset="0"/>
-                                    </a:rPr>
-                                    <m:t>𝑡</m:t>
-                                  </m:r>
-                                  <m:r>
-                                    <a:rPr lang="de-DE" sz="2400" i="1">
-                                      <a:solidFill>
-                                        <a:schemeClr val="tx1"/>
-                                      </a:solidFill>
-                                      <a:latin typeface="Cambria Math" panose="02040503050406030204" pitchFamily="18" charset="0"/>
-                                    </a:rPr>
-                                    <m:t>−1</m:t>
-                                  </m:r>
-                                </m:sub>
-                              </m:sSub>
-                              <m:r>
-                                <a:rPr lang="de-DE" sz="2400" i="1">
-                                  <a:solidFill>
-                                    <a:schemeClr val="tx1"/>
-                                  </a:solidFill>
-                                  <a:latin typeface="Cambria Math" panose="02040503050406030204" pitchFamily="18" charset="0"/>
-                                </a:rPr>
-                                <m:t>+</m:t>
-                              </m:r>
-                              <m:r>
-                                <a:rPr lang="de-DE" sz="2400" i="1">
-                                  <a:solidFill>
-                                    <a:schemeClr val="tx1"/>
-                                  </a:solidFill>
-                                  <a:latin typeface="Cambria Math" panose="02040503050406030204" pitchFamily="18" charset="0"/>
-                                </a:rPr>
-                                <m:t>𝑏</m:t>
-                              </m:r>
-                              <m:r>
                                 <a:rPr lang="de-DE" sz="2400" b="0" i="1" smtClean="0">
                                   <a:solidFill>
                                     <a:schemeClr val="tx1"/>
@@ -11939,8 +11767,8 @@
             </p:nvSpPr>
             <p:spPr>
               <a:xfrm>
-                <a:off x="12607034" y="1392425"/>
-                <a:ext cx="4106573" cy="2871189"/>
+                <a:off x="7946474" y="4545597"/>
+                <a:ext cx="2507295" cy="1502310"/>
               </a:xfrm>
               <a:prstGeom prst="roundRect">
                 <a:avLst>
@@ -11977,83 +11805,10 @@
           </p:sp>
         </mc:Fallback>
       </mc:AlternateContent>
-      <p:sp>
-        <p:nvSpPr>
-          <p:cNvPr id="10" name="TextBox 9"/>
-          <p:cNvSpPr txBox="1"/>
-          <p:nvPr/>
-        </p:nvSpPr>
-        <p:spPr>
-          <a:xfrm>
-            <a:off x="927100" y="1886858"/>
-            <a:ext cx="10337800" cy="3108543"/>
-          </a:xfrm>
-          <a:prstGeom prst="rect">
-            <a:avLst/>
-          </a:prstGeom>
-          <a:noFill/>
-        </p:spPr>
-        <p:txBody>
-          <a:bodyPr wrap="square" rtlCol="0">
-            <a:spAutoFit/>
-          </a:bodyPr>
-          <a:lstStyle/>
-          <a:p>
-            <a:r>
-              <a:rPr lang="de-DE" sz="2800" dirty="0">
-                <a:latin typeface="Bahnschrift" panose="020B0502040204020203" pitchFamily="34" charset="0"/>
-              </a:rPr>
-              <a:t>For each side</a:t>
-            </a:r>
-            <a:r>
-              <a:rPr lang="de-DE" sz="2800" dirty="0" smtClean="0">
-                <a:latin typeface="Bahnschrift" panose="020B0502040204020203" pitchFamily="34" charset="0"/>
-              </a:rPr>
-              <a:t>:</a:t>
-            </a:r>
-          </a:p>
-          <a:p>
-            <a:endParaRPr lang="de-DE" sz="2800" dirty="0">
-              <a:latin typeface="Bahnschrift" panose="020B0502040204020203" pitchFamily="34" charset="0"/>
-            </a:endParaRPr>
-          </a:p>
-          <a:p>
-            <a:endParaRPr lang="de-DE" sz="2800" dirty="0" smtClean="0">
-              <a:latin typeface="Bahnschrift" panose="020B0502040204020203" pitchFamily="34" charset="0"/>
-            </a:endParaRPr>
-          </a:p>
-          <a:p>
-            <a:endParaRPr lang="de-DE" sz="2800" dirty="0">
-              <a:latin typeface="Bahnschrift" panose="020B0502040204020203" pitchFamily="34" charset="0"/>
-            </a:endParaRPr>
-          </a:p>
-          <a:p>
-            <a:endParaRPr lang="de-DE" sz="2800" dirty="0" smtClean="0">
-              <a:latin typeface="Bahnschrift" panose="020B0502040204020203" pitchFamily="34" charset="0"/>
-            </a:endParaRPr>
-          </a:p>
-          <a:p>
-            <a:r>
-              <a:rPr lang="de-DE" sz="2800" dirty="0" smtClean="0">
-                <a:latin typeface="Bahnschrift" panose="020B0502040204020203" pitchFamily="34" charset="0"/>
-              </a:rPr>
-              <a:t>Their difference is used to calculate the probability to gamble:</a:t>
-            </a:r>
-            <a:endParaRPr lang="de-DE" sz="2800" dirty="0">
-              <a:latin typeface="Bahnschrift" panose="020B0502040204020203" pitchFamily="34" charset="0"/>
-            </a:endParaRPr>
-          </a:p>
-          <a:p>
-            <a:endParaRPr lang="en-GB" sz="2800" dirty="0">
-              <a:latin typeface="Bahnschrift" panose="020B0502040204020203" pitchFamily="34" charset="0"/>
-            </a:endParaRPr>
-          </a:p>
-        </p:txBody>
-      </p:sp>
     </p:spTree>
     <p:extLst>
       <p:ext uri="{BB962C8B-B14F-4D97-AF65-F5344CB8AC3E}">
-        <p14:creationId xmlns:p14="http://schemas.microsoft.com/office/powerpoint/2010/main" val="2438381814"/>
+        <p14:creationId xmlns:p14="http://schemas.microsoft.com/office/powerpoint/2010/main" val="1249006926"/>
       </p:ext>
     </p:extLst>
   </p:cSld>
@@ -12063,9 +11818,237 @@
   <p:timing>
     <p:tnLst>
       <p:par>
-        <p:cTn id="1" dur="indefinite" restart="never" nodeType="tmRoot"/>
+        <p:cTn id="1" dur="indefinite" restart="never" nodeType="tmRoot">
+          <p:childTnLst>
+            <p:seq concurrent="1" nextAc="seek">
+              <p:cTn id="2" dur="indefinite" nodeType="mainSeq">
+                <p:childTnLst>
+                  <p:par>
+                    <p:cTn id="3" fill="hold">
+                      <p:stCondLst>
+                        <p:cond delay="indefinite"/>
+                        <p:cond evt="onBegin" delay="0">
+                          <p:tn val="2"/>
+                        </p:cond>
+                      </p:stCondLst>
+                      <p:childTnLst>
+                        <p:par>
+                          <p:cTn id="4" fill="hold">
+                            <p:stCondLst>
+                              <p:cond delay="0"/>
+                            </p:stCondLst>
+                            <p:childTnLst>
+                              <p:par>
+                                <p:cTn id="5" presetID="1" presetClass="exit" presetSubtype="0" fill="hold" grpId="2" nodeType="withEffect">
+                                  <p:stCondLst>
+                                    <p:cond delay="0"/>
+                                  </p:stCondLst>
+                                  <p:childTnLst>
+                                    <p:set>
+                                      <p:cBhvr>
+                                        <p:cTn id="6" dur="1" fill="hold">
+                                          <p:stCondLst>
+                                            <p:cond delay="0"/>
+                                          </p:stCondLst>
+                                        </p:cTn>
+                                        <p:tgtEl>
+                                          <p:spTgt spid="9"/>
+                                        </p:tgtEl>
+                                        <p:attrNameLst>
+                                          <p:attrName>style.visibility</p:attrName>
+                                        </p:attrNameLst>
+                                      </p:cBhvr>
+                                      <p:to>
+                                        <p:strVal val="hidden"/>
+                                      </p:to>
+                                    </p:set>
+                                  </p:childTnLst>
+                                </p:cTn>
+                              </p:par>
+                            </p:childTnLst>
+                          </p:cTn>
+                        </p:par>
+                      </p:childTnLst>
+                    </p:cTn>
+                  </p:par>
+                  <p:par>
+                    <p:cTn id="7" fill="hold">
+                      <p:stCondLst>
+                        <p:cond delay="indefinite"/>
+                      </p:stCondLst>
+                      <p:childTnLst>
+                        <p:par>
+                          <p:cTn id="8" fill="hold">
+                            <p:stCondLst>
+                              <p:cond delay="0"/>
+                            </p:stCondLst>
+                            <p:childTnLst>
+                              <p:par>
+                                <p:cTn id="9" presetID="53" presetClass="entr" presetSubtype="16" fill="hold" grpId="0" nodeType="clickEffect">
+                                  <p:stCondLst>
+                                    <p:cond delay="0"/>
+                                  </p:stCondLst>
+                                  <p:childTnLst>
+                                    <p:set>
+                                      <p:cBhvr>
+                                        <p:cTn id="10" dur="1" fill="hold">
+                                          <p:stCondLst>
+                                            <p:cond delay="0"/>
+                                          </p:stCondLst>
+                                        </p:cTn>
+                                        <p:tgtEl>
+                                          <p:spTgt spid="9"/>
+                                        </p:tgtEl>
+                                        <p:attrNameLst>
+                                          <p:attrName>style.visibility</p:attrName>
+                                        </p:attrNameLst>
+                                      </p:cBhvr>
+                                      <p:to>
+                                        <p:strVal val="visible"/>
+                                      </p:to>
+                                    </p:set>
+                                    <p:anim calcmode="lin" valueType="num">
+                                      <p:cBhvr>
+                                        <p:cTn id="11" dur="250" fill="hold"/>
+                                        <p:tgtEl>
+                                          <p:spTgt spid="9"/>
+                                        </p:tgtEl>
+                                        <p:attrNameLst>
+                                          <p:attrName>ppt_w</p:attrName>
+                                        </p:attrNameLst>
+                                      </p:cBhvr>
+                                      <p:tavLst>
+                                        <p:tav tm="0">
+                                          <p:val>
+                                            <p:fltVal val="0"/>
+                                          </p:val>
+                                        </p:tav>
+                                        <p:tav tm="100000">
+                                          <p:val>
+                                            <p:strVal val="#ppt_w"/>
+                                          </p:val>
+                                        </p:tav>
+                                      </p:tavLst>
+                                    </p:anim>
+                                    <p:anim calcmode="lin" valueType="num">
+                                      <p:cBhvr>
+                                        <p:cTn id="12" dur="250" fill="hold"/>
+                                        <p:tgtEl>
+                                          <p:spTgt spid="9"/>
+                                        </p:tgtEl>
+                                        <p:attrNameLst>
+                                          <p:attrName>ppt_h</p:attrName>
+                                        </p:attrNameLst>
+                                      </p:cBhvr>
+                                      <p:tavLst>
+                                        <p:tav tm="0">
+                                          <p:val>
+                                            <p:fltVal val="0"/>
+                                          </p:val>
+                                        </p:tav>
+                                        <p:tav tm="100000">
+                                          <p:val>
+                                            <p:strVal val="#ppt_h"/>
+                                          </p:val>
+                                        </p:tav>
+                                      </p:tavLst>
+                                    </p:anim>
+                                    <p:animEffect transition="in" filter="fade">
+                                      <p:cBhvr>
+                                        <p:cTn id="13" dur="250"/>
+                                        <p:tgtEl>
+                                          <p:spTgt spid="9"/>
+                                        </p:tgtEl>
+                                      </p:cBhvr>
+                                    </p:animEffect>
+                                  </p:childTnLst>
+                                </p:cTn>
+                              </p:par>
+                            </p:childTnLst>
+                          </p:cTn>
+                        </p:par>
+                      </p:childTnLst>
+                    </p:cTn>
+                  </p:par>
+                  <p:par>
+                    <p:cTn id="14" fill="hold">
+                      <p:stCondLst>
+                        <p:cond delay="indefinite"/>
+                      </p:stCondLst>
+                      <p:childTnLst>
+                        <p:par>
+                          <p:cTn id="15" fill="hold">
+                            <p:stCondLst>
+                              <p:cond delay="0"/>
+                            </p:stCondLst>
+                            <p:childTnLst>
+                              <p:par>
+                                <p:cTn id="16" presetID="10" presetClass="exit" presetSubtype="0" fill="hold" grpId="1" nodeType="clickEffect">
+                                  <p:stCondLst>
+                                    <p:cond delay="0"/>
+                                  </p:stCondLst>
+                                  <p:childTnLst>
+                                    <p:animEffect transition="out" filter="fade">
+                                      <p:cBhvr>
+                                        <p:cTn id="17" dur="250"/>
+                                        <p:tgtEl>
+                                          <p:spTgt spid="9"/>
+                                        </p:tgtEl>
+                                      </p:cBhvr>
+                                    </p:animEffect>
+                                    <p:set>
+                                      <p:cBhvr>
+                                        <p:cTn id="18" dur="1" fill="hold">
+                                          <p:stCondLst>
+                                            <p:cond delay="249"/>
+                                          </p:stCondLst>
+                                        </p:cTn>
+                                        <p:tgtEl>
+                                          <p:spTgt spid="9"/>
+                                        </p:tgtEl>
+                                        <p:attrNameLst>
+                                          <p:attrName>style.visibility</p:attrName>
+                                        </p:attrNameLst>
+                                      </p:cBhvr>
+                                      <p:to>
+                                        <p:strVal val="hidden"/>
+                                      </p:to>
+                                    </p:set>
+                                  </p:childTnLst>
+                                </p:cTn>
+                              </p:par>
+                            </p:childTnLst>
+                          </p:cTn>
+                        </p:par>
+                      </p:childTnLst>
+                    </p:cTn>
+                  </p:par>
+                </p:childTnLst>
+              </p:cTn>
+              <p:prevCondLst>
+                <p:cond evt="onPrev" delay="0">
+                  <p:tgtEl>
+                    <p:sldTgt/>
+                  </p:tgtEl>
+                </p:cond>
+              </p:prevCondLst>
+              <p:nextCondLst>
+                <p:cond evt="onNext" delay="0">
+                  <p:tgtEl>
+                    <p:sldTgt/>
+                  </p:tgtEl>
+                </p:cond>
+              </p:nextCondLst>
+            </p:seq>
+          </p:childTnLst>
+        </p:cTn>
       </p:par>
     </p:tnLst>
+    <p:bldLst>
+      <p:bldP spid="9" grpId="0" animBg="1"/>
+      <p:bldP spid="9" grpId="1" animBg="1"/>
+      <p:bldP spid="9" grpId="2" animBg="1"/>
+    </p:bldLst>
   </p:timing>
 </p:sld>
 </file>
@@ -12745,7 +12728,7 @@
                 <a:lstStyle/>
                 <a:p>
                   <a:pPr algn="ctr"/>
-                  <a:endParaRPr lang="en-GB" sz="2800" i="1" dirty="0">
+                  <a:endParaRPr lang="en-GB" sz="2800" i="1" dirty="0" smtClean="0">
                     <a:solidFill>
                       <a:schemeClr val="tx1"/>
                     </a:solidFill>
@@ -12767,10 +12750,59 @@
                   <a:pPr algn="ctr"/>
                   <a14:m>
                     <m:oMath xmlns:m="http://schemas.openxmlformats.org/officeDocument/2006/math">
+                      <m:r>
+                        <a:rPr lang="de-DE" sz="2400" i="1" smtClean="0">
+                          <a:solidFill>
+                            <a:schemeClr val="tx1"/>
+                          </a:solidFill>
+                          <a:latin typeface="Cambria Math" panose="02040503050406030204" pitchFamily="18" charset="0"/>
+                        </a:rPr>
+                        <m:t>𝛽</m:t>
+                      </m:r>
+                      <m:r>
+                        <a:rPr lang="de-DE" sz="2400" b="0" i="1" smtClean="0">
+                          <a:solidFill>
+                            <a:schemeClr val="tx1"/>
+                          </a:solidFill>
+                          <a:latin typeface="Cambria Math" panose="02040503050406030204" pitchFamily="18" charset="0"/>
+                        </a:rPr>
+                        <m:t>=</m:t>
+                      </m:r>
+                    </m:oMath>
+                  </a14:m>
+                  <a:r>
+                    <a:rPr lang="de-DE" sz="2400" dirty="0" smtClean="0">
+                      <a:solidFill>
+                        <a:schemeClr val="tx1"/>
+                      </a:solidFill>
+                      <a:ea typeface="Cambria Math" panose="02040503050406030204" pitchFamily="18" charset="0"/>
+                    </a:rPr>
+                    <a:t> </a:t>
+                  </a:r>
+                  <a:r>
+                    <a:rPr lang="de-DE" sz="2400" dirty="0" smtClean="0">
+                      <a:solidFill>
+                        <a:schemeClr val="tx1"/>
+                      </a:solidFill>
+                      <a:latin typeface="Bahnschrift" panose="020B0502040204020203" pitchFamily="34" charset="0"/>
+                    </a:rPr>
+                    <a:t>temperature;</a:t>
+                  </a:r>
+                  <a:r>
+                    <a:rPr lang="de-DE" sz="2400" dirty="0" smtClean="0">
+                      <a:solidFill>
+                        <a:schemeClr val="tx1"/>
+                      </a:solidFill>
+                      <a:ea typeface="Cambria Math" panose="02040503050406030204" pitchFamily="18" charset="0"/>
+                    </a:rPr>
+                    <a:t> </a:t>
+                  </a:r>
+                  <a14:m>
+                    <m:oMath xmlns:m="http://schemas.openxmlformats.org/officeDocument/2006/math">
                       <m:sSub>
                         <m:sSubPr>
                           <m:ctrlPr>
-                            <a:rPr lang="de-DE" sz="2400" i="1">
+                            <a:rPr lang="de-DE" sz="2400" i="1" smtClean="0">
                               <a:solidFill>
                                 <a:schemeClr val="tx1"/>
                               </a:solidFill>
@@ -13176,6 +13208,79 @@
           </mc:Fallback>
         </mc:AlternateContent>
       </p:grpSp>
+      <p:sp>
+        <p:nvSpPr>
+          <p:cNvPr id="10" name="TextBox 9"/>
+          <p:cNvSpPr txBox="1"/>
+          <p:nvPr/>
+        </p:nvSpPr>
+        <p:spPr>
+          <a:xfrm>
+            <a:off x="927100" y="1886858"/>
+            <a:ext cx="10337800" cy="3108543"/>
+          </a:xfrm>
+          <a:prstGeom prst="rect">
+            <a:avLst/>
+          </a:prstGeom>
+          <a:noFill/>
+        </p:spPr>
+        <p:txBody>
+          <a:bodyPr wrap="square" rtlCol="0">
+            <a:spAutoFit/>
+          </a:bodyPr>
+          <a:lstStyle/>
+          <a:p>
+            <a:r>
+              <a:rPr lang="de-DE" sz="2800" dirty="0">
+                <a:latin typeface="Bahnschrift" panose="020B0502040204020203" pitchFamily="34" charset="0"/>
+              </a:rPr>
+              <a:t>For each side</a:t>
+            </a:r>
+            <a:r>
+              <a:rPr lang="de-DE" sz="2800" dirty="0" smtClean="0">
+                <a:latin typeface="Bahnschrift" panose="020B0502040204020203" pitchFamily="34" charset="0"/>
+              </a:rPr>
+              <a:t>:</a:t>
+            </a:r>
+          </a:p>
+          <a:p>
+            <a:endParaRPr lang="de-DE" sz="2800" dirty="0">
+              <a:latin typeface="Bahnschrift" panose="020B0502040204020203" pitchFamily="34" charset="0"/>
+            </a:endParaRPr>
+          </a:p>
+          <a:p>
+            <a:endParaRPr lang="de-DE" sz="2800" dirty="0" smtClean="0">
+              <a:latin typeface="Bahnschrift" panose="020B0502040204020203" pitchFamily="34" charset="0"/>
+            </a:endParaRPr>
+          </a:p>
+          <a:p>
+            <a:endParaRPr lang="de-DE" sz="2800" dirty="0">
+              <a:latin typeface="Bahnschrift" panose="020B0502040204020203" pitchFamily="34" charset="0"/>
+            </a:endParaRPr>
+          </a:p>
+          <a:p>
+            <a:endParaRPr lang="de-DE" sz="2800" dirty="0" smtClean="0">
+              <a:latin typeface="Bahnschrift" panose="020B0502040204020203" pitchFamily="34" charset="0"/>
+            </a:endParaRPr>
+          </a:p>
+          <a:p>
+            <a:r>
+              <a:rPr lang="de-DE" sz="2800" dirty="0" smtClean="0">
+                <a:latin typeface="Bahnschrift" panose="020B0502040204020203" pitchFamily="34" charset="0"/>
+              </a:rPr>
+              <a:t>Their difference is used to calculate the probability to gamble:</a:t>
+            </a:r>
+            <a:endParaRPr lang="de-DE" sz="2800" dirty="0">
+              <a:latin typeface="Bahnschrift" panose="020B0502040204020203" pitchFamily="34" charset="0"/>
+            </a:endParaRPr>
+          </a:p>
+          <a:p>
+            <a:endParaRPr lang="en-GB" sz="2800" dirty="0">
+              <a:latin typeface="Bahnschrift" panose="020B0502040204020203" pitchFamily="34" charset="0"/>
+            </a:endParaRPr>
+          </a:p>
+        </p:txBody>
+      </p:sp>
       <mc:AlternateContent xmlns:mc="http://schemas.openxmlformats.org/markup-compatibility/2006">
         <mc:Choice xmlns:a14="http://schemas.microsoft.com/office/drawing/2010/main" Requires="a14">
           <p:sp>
@@ -13186,7 +13291,7 @@
             </p:nvSpPr>
             <p:spPr>
               <a:xfrm>
-                <a:off x="12607034" y="1392425"/>
+                <a:off x="12557098" y="2439693"/>
                 <a:ext cx="4106573" cy="2871189"/>
               </a:xfrm>
               <a:prstGeom prst="roundRect">
@@ -13458,7 +13563,7 @@
             </p:nvSpPr>
             <p:spPr>
               <a:xfrm>
-                <a:off x="12607034" y="1392425"/>
+                <a:off x="12557098" y="2439693"/>
                 <a:ext cx="4106573" cy="2871189"/>
               </a:xfrm>
               <a:prstGeom prst="roundRect">
@@ -13496,83 +13601,10 @@
           </p:sp>
         </mc:Fallback>
       </mc:AlternateContent>
-      <p:sp>
-        <p:nvSpPr>
-          <p:cNvPr id="10" name="TextBox 9"/>
-          <p:cNvSpPr txBox="1"/>
-          <p:nvPr/>
-        </p:nvSpPr>
-        <p:spPr>
-          <a:xfrm>
-            <a:off x="927100" y="1886858"/>
-            <a:ext cx="10337800" cy="3108543"/>
-          </a:xfrm>
-          <a:prstGeom prst="rect">
-            <a:avLst/>
-          </a:prstGeom>
-          <a:noFill/>
-        </p:spPr>
-        <p:txBody>
-          <a:bodyPr wrap="square" rtlCol="0">
-            <a:spAutoFit/>
-          </a:bodyPr>
-          <a:lstStyle/>
-          <a:p>
-            <a:r>
-              <a:rPr lang="de-DE" sz="2800" dirty="0">
-                <a:latin typeface="Bahnschrift" panose="020B0502040204020203" pitchFamily="34" charset="0"/>
-              </a:rPr>
-              <a:t>For each side</a:t>
-            </a:r>
-            <a:r>
-              <a:rPr lang="de-DE" sz="2800" dirty="0" smtClean="0">
-                <a:latin typeface="Bahnschrift" panose="020B0502040204020203" pitchFamily="34" charset="0"/>
-              </a:rPr>
-              <a:t>:</a:t>
-            </a:r>
-          </a:p>
-          <a:p>
-            <a:endParaRPr lang="de-DE" sz="2800" dirty="0">
-              <a:latin typeface="Bahnschrift" panose="020B0502040204020203" pitchFamily="34" charset="0"/>
-            </a:endParaRPr>
-          </a:p>
-          <a:p>
-            <a:endParaRPr lang="de-DE" sz="2800" dirty="0" smtClean="0">
-              <a:latin typeface="Bahnschrift" panose="020B0502040204020203" pitchFamily="34" charset="0"/>
-            </a:endParaRPr>
-          </a:p>
-          <a:p>
-            <a:endParaRPr lang="de-DE" sz="2800" dirty="0">
-              <a:latin typeface="Bahnschrift" panose="020B0502040204020203" pitchFamily="34" charset="0"/>
-            </a:endParaRPr>
-          </a:p>
-          <a:p>
-            <a:endParaRPr lang="de-DE" sz="2800" dirty="0" smtClean="0">
-              <a:latin typeface="Bahnschrift" panose="020B0502040204020203" pitchFamily="34" charset="0"/>
-            </a:endParaRPr>
-          </a:p>
-          <a:p>
-            <a:r>
-              <a:rPr lang="de-DE" sz="2800" dirty="0" smtClean="0">
-                <a:latin typeface="Bahnschrift" panose="020B0502040204020203" pitchFamily="34" charset="0"/>
-              </a:rPr>
-              <a:t>Their difference is used to calculate the probability to gamble:</a:t>
-            </a:r>
-            <a:endParaRPr lang="de-DE" sz="2800" dirty="0">
-              <a:latin typeface="Bahnschrift" panose="020B0502040204020203" pitchFamily="34" charset="0"/>
-            </a:endParaRPr>
-          </a:p>
-          <a:p>
-            <a:endParaRPr lang="en-GB" sz="2800" dirty="0">
-              <a:latin typeface="Bahnschrift" panose="020B0502040204020203" pitchFamily="34" charset="0"/>
-            </a:endParaRPr>
-          </a:p>
-        </p:txBody>
-      </p:sp>
     </p:spTree>
     <p:extLst>
       <p:ext uri="{BB962C8B-B14F-4D97-AF65-F5344CB8AC3E}">
-        <p14:creationId xmlns:p14="http://schemas.microsoft.com/office/powerpoint/2010/main" val="1249006926"/>
+        <p14:creationId xmlns:p14="http://schemas.microsoft.com/office/powerpoint/2010/main" val="3493098249"/>
       </p:ext>
     </p:extLst>
   </p:cSld>
@@ -14104,23 +14136,81 @@
       </p:sp>
       <p:sp>
         <p:nvSpPr>
-          <p:cNvPr id="3" name="Content Placeholder 2"/>
-          <p:cNvSpPr>
-            <a:spLocks noGrp="1"/>
-          </p:cNvSpPr>
+          <p:cNvPr id="5" name="Rectangle 4"/>
+          <p:cNvSpPr/>
+          <p:nvPr/>
+        </p:nvSpPr>
+        <p:spPr>
+          <a:xfrm>
+            <a:off x="-162839" y="5723898"/>
+            <a:ext cx="12776548" cy="1803748"/>
+          </a:xfrm>
+          <a:prstGeom prst="rect">
+            <a:avLst/>
+          </a:prstGeom>
+          <a:solidFill>
+            <a:srgbClr val="CFF1E6"/>
+          </a:solidFill>
+          <a:ln w="76200">
+            <a:solidFill>
+              <a:srgbClr val="0CB87F"/>
+            </a:solidFill>
+          </a:ln>
+        </p:spPr>
+        <p:style>
+          <a:lnRef idx="2">
+            <a:schemeClr val="accent1">
+              <a:shade val="50000"/>
+            </a:schemeClr>
+          </a:lnRef>
+          <a:fillRef idx="1">
+            <a:schemeClr val="accent1"/>
+          </a:fillRef>
+          <a:effectRef idx="0">
+            <a:schemeClr val="accent1"/>
+          </a:effectRef>
+          <a:fontRef idx="minor">
+            <a:schemeClr val="lt1"/>
+          </a:fontRef>
+        </p:style>
+        <p:txBody>
+          <a:bodyPr rtlCol="0" anchor="ctr"/>
+          <a:lstStyle/>
+          <a:p>
+            <a:pPr algn="ctr"/>
+            <a:endParaRPr lang="en-GB" dirty="0"/>
+          </a:p>
+        </p:txBody>
+      </p:sp>
+      <p:pic>
+        <p:nvPicPr>
+          <p:cNvPr id="9" name="Content Placeholder 8"/>
+          <p:cNvPicPr>
+            <a:picLocks noGrp="1" noChangeAspect="1"/>
+          </p:cNvPicPr>
           <p:nvPr>
             <p:ph idx="1"/>
           </p:nvPr>
-        </p:nvSpPr>
-        <p:spPr/>
-        <p:txBody>
-          <a:bodyPr/>
-          <a:lstStyle/>
-          <a:p>
-            <a:endParaRPr lang="en-GB"/>
-          </a:p>
-        </p:txBody>
-      </p:sp>
+        </p:nvPicPr>
+        <p:blipFill>
+          <a:blip r:embed="rId2">
+            <a:extLst>
+              <a:ext uri="{28A0092B-C50C-407E-A947-70E740481C1C}">
+                <a14:useLocalDpi xmlns:a14="http://schemas.microsoft.com/office/drawing/2010/main" val="0"/>
+              </a:ext>
+            </a:extLst>
+          </a:blip>
+          <a:stretch>
+            <a:fillRect/>
+          </a:stretch>
+        </p:blipFill>
+        <p:spPr>
+          <a:xfrm>
+            <a:off x="0" y="181426"/>
+            <a:ext cx="12192000" cy="6502401"/>
+          </a:xfrm>
+        </p:spPr>
+      </p:pic>
     </p:spTree>
     <p:extLst>
       <p:ext uri="{BB962C8B-B14F-4D97-AF65-F5344CB8AC3E}">
@@ -14305,6 +14395,13 @@
   <p:clrMapOvr>
     <a:masterClrMapping/>
   </p:clrMapOvr>
+  <p:timing>
+    <p:tnLst>
+      <p:par>
+        <p:cTn id="1" dur="indefinite" restart="never" nodeType="tmRoot"/>
+      </p:par>
+    </p:tnLst>
+  </p:timing>
 </p:sld>
 </file>
 
@@ -14371,6 +14468,36 @@
           </a:p>
         </p:txBody>
       </p:sp>
+      <p:pic>
+        <p:nvPicPr>
+          <p:cNvPr id="4" name="Picture 3"/>
+          <p:cNvPicPr>
+            <a:picLocks noChangeAspect="1"/>
+          </p:cNvPicPr>
+          <p:nvPr/>
+        </p:nvPicPr>
+        <p:blipFill>
+          <a:blip r:embed="rId2">
+            <a:extLst>
+              <a:ext uri="{28A0092B-C50C-407E-A947-70E740481C1C}">
+                <a14:useLocalDpi xmlns:a14="http://schemas.microsoft.com/office/drawing/2010/main" val="0"/>
+              </a:ext>
+            </a:extLst>
+          </a:blip>
+          <a:stretch>
+            <a:fillRect/>
+          </a:stretch>
+        </p:blipFill>
+        <p:spPr>
+          <a:xfrm>
+            <a:off x="1376036" y="1150609"/>
+            <a:ext cx="8725907" cy="5026354"/>
+          </a:xfrm>
+          <a:prstGeom prst="rect">
+            <a:avLst/>
+          </a:prstGeom>
+        </p:spPr>
+      </p:pic>
     </p:spTree>
     <p:extLst>
       <p:ext uri="{BB962C8B-B14F-4D97-AF65-F5344CB8AC3E}">
@@ -14381,6 +14508,296 @@
   <p:clrMapOvr>
     <a:masterClrMapping/>
   </p:clrMapOvr>
+  <p:timing>
+    <p:tnLst>
+      <p:par>
+        <p:cTn id="1" dur="indefinite" restart="never" nodeType="tmRoot"/>
+      </p:par>
+    </p:tnLst>
+  </p:timing>
+</p:sld>
+</file>
+
+<file path=ppt/slides/slide27.xml><?xml version="1.0" encoding="utf-8"?>
+<p:sld xmlns:a="http://schemas.openxmlformats.org/drawingml/2006/main" xmlns:r="http://schemas.openxmlformats.org/officeDocument/2006/relationships" xmlns:p="http://schemas.openxmlformats.org/presentationml/2006/main">
+  <p:cSld>
+    <p:spTree>
+      <p:nvGrpSpPr>
+        <p:cNvPr id="1" name=""/>
+        <p:cNvGrpSpPr/>
+        <p:nvPr/>
+      </p:nvGrpSpPr>
+      <p:grpSpPr>
+        <a:xfrm>
+          <a:off x="0" y="0"/>
+          <a:ext cx="0" cy="0"/>
+          <a:chOff x="0" y="0"/>
+          <a:chExt cx="0" cy="0"/>
+        </a:xfrm>
+      </p:grpSpPr>
+      <p:sp>
+        <p:nvSpPr>
+          <p:cNvPr id="2" name="Title 1"/>
+          <p:cNvSpPr>
+            <a:spLocks noGrp="1"/>
+          </p:cNvSpPr>
+          <p:nvPr>
+            <p:ph type="title"/>
+          </p:nvPr>
+        </p:nvSpPr>
+        <p:spPr/>
+        <p:txBody>
+          <a:bodyPr/>
+          <a:lstStyle/>
+          <a:p>
+            <a:endParaRPr lang="en-GB"/>
+          </a:p>
+        </p:txBody>
+      </p:sp>
+      <p:sp>
+        <p:nvSpPr>
+          <p:cNvPr id="5" name="Rectangle 4"/>
+          <p:cNvSpPr/>
+          <p:nvPr/>
+        </p:nvSpPr>
+        <p:spPr>
+          <a:xfrm>
+            <a:off x="-316590" y="5583745"/>
+            <a:ext cx="12776548" cy="1803748"/>
+          </a:xfrm>
+          <a:prstGeom prst="rect">
+            <a:avLst/>
+          </a:prstGeom>
+          <a:solidFill>
+            <a:srgbClr val="CFF1E6"/>
+          </a:solidFill>
+          <a:ln w="76200">
+            <a:solidFill>
+              <a:srgbClr val="0CB87F"/>
+            </a:solidFill>
+          </a:ln>
+        </p:spPr>
+        <p:style>
+          <a:lnRef idx="2">
+            <a:schemeClr val="accent1">
+              <a:shade val="50000"/>
+            </a:schemeClr>
+          </a:lnRef>
+          <a:fillRef idx="1">
+            <a:schemeClr val="accent1"/>
+          </a:fillRef>
+          <a:effectRef idx="0">
+            <a:schemeClr val="accent1"/>
+          </a:effectRef>
+          <a:fontRef idx="minor">
+            <a:schemeClr val="lt1"/>
+          </a:fontRef>
+        </p:style>
+        <p:txBody>
+          <a:bodyPr rtlCol="0" anchor="ctr"/>
+          <a:lstStyle/>
+          <a:p>
+            <a:pPr algn="ctr"/>
+            <a:endParaRPr lang="en-GB" dirty="0"/>
+          </a:p>
+        </p:txBody>
+      </p:sp>
+      <p:pic>
+        <p:nvPicPr>
+          <p:cNvPr id="4" name="Content Placeholder 3"/>
+          <p:cNvPicPr>
+            <a:picLocks noGrp="1" noChangeAspect="1"/>
+          </p:cNvPicPr>
+          <p:nvPr>
+            <p:ph idx="1"/>
+          </p:nvPr>
+        </p:nvPicPr>
+        <p:blipFill>
+          <a:blip r:embed="rId2">
+            <a:extLst>
+              <a:ext uri="{28A0092B-C50C-407E-A947-70E740481C1C}">
+                <a14:useLocalDpi xmlns:a14="http://schemas.microsoft.com/office/drawing/2010/main" val="0"/>
+              </a:ext>
+            </a:extLst>
+          </a:blip>
+          <a:stretch>
+            <a:fillRect/>
+          </a:stretch>
+        </p:blipFill>
+        <p:spPr>
+          <a:xfrm>
+            <a:off x="0" y="566058"/>
+            <a:ext cx="12192000" cy="5741530"/>
+          </a:xfrm>
+        </p:spPr>
+      </p:pic>
+    </p:spTree>
+    <p:extLst>
+      <p:ext uri="{BB962C8B-B14F-4D97-AF65-F5344CB8AC3E}">
+        <p14:creationId xmlns:p14="http://schemas.microsoft.com/office/powerpoint/2010/main" val="1339492739"/>
+      </p:ext>
+    </p:extLst>
+  </p:cSld>
+  <p:clrMapOvr>
+    <a:masterClrMapping/>
+  </p:clrMapOvr>
+  <p:timing>
+    <p:tnLst>
+      <p:par>
+        <p:cTn id="1" dur="indefinite" restart="never" nodeType="tmRoot"/>
+      </p:par>
+    </p:tnLst>
+  </p:timing>
+</p:sld>
+</file>
+
+<file path=ppt/slides/slide28.xml><?xml version="1.0" encoding="utf-8"?>
+<p:sld xmlns:a="http://schemas.openxmlformats.org/drawingml/2006/main" xmlns:r="http://schemas.openxmlformats.org/officeDocument/2006/relationships" xmlns:p="http://schemas.openxmlformats.org/presentationml/2006/main">
+  <p:cSld>
+    <p:spTree>
+      <p:nvGrpSpPr>
+        <p:cNvPr id="1" name=""/>
+        <p:cNvGrpSpPr/>
+        <p:nvPr/>
+      </p:nvGrpSpPr>
+      <p:grpSpPr>
+        <a:xfrm>
+          <a:off x="0" y="0"/>
+          <a:ext cx="0" cy="0"/>
+          <a:chOff x="0" y="0"/>
+          <a:chExt cx="0" cy="0"/>
+        </a:xfrm>
+      </p:grpSpPr>
+      <p:sp>
+        <p:nvSpPr>
+          <p:cNvPr id="2" name="Title 1"/>
+          <p:cNvSpPr>
+            <a:spLocks noGrp="1"/>
+          </p:cNvSpPr>
+          <p:nvPr>
+            <p:ph type="title"/>
+          </p:nvPr>
+        </p:nvSpPr>
+        <p:spPr/>
+        <p:txBody>
+          <a:bodyPr/>
+          <a:lstStyle/>
+          <a:p>
+            <a:endParaRPr lang="en-GB"/>
+          </a:p>
+        </p:txBody>
+      </p:sp>
+      <p:sp>
+        <p:nvSpPr>
+          <p:cNvPr id="3" name="Content Placeholder 2"/>
+          <p:cNvSpPr>
+            <a:spLocks noGrp="1"/>
+          </p:cNvSpPr>
+          <p:nvPr>
+            <p:ph idx="1"/>
+          </p:nvPr>
+        </p:nvSpPr>
+        <p:spPr/>
+        <p:txBody>
+          <a:bodyPr/>
+          <a:lstStyle/>
+          <a:p>
+            <a:endParaRPr lang="en-GB"/>
+          </a:p>
+        </p:txBody>
+      </p:sp>
+    </p:spTree>
+    <p:extLst>
+      <p:ext uri="{BB962C8B-B14F-4D97-AF65-F5344CB8AC3E}">
+        <p14:creationId xmlns:p14="http://schemas.microsoft.com/office/powerpoint/2010/main" val="1144621004"/>
+      </p:ext>
+    </p:extLst>
+  </p:cSld>
+  <p:clrMapOvr>
+    <a:masterClrMapping/>
+  </p:clrMapOvr>
+  <p:timing>
+    <p:tnLst>
+      <p:par>
+        <p:cTn id="1" dur="indefinite" restart="never" nodeType="tmRoot"/>
+      </p:par>
+    </p:tnLst>
+  </p:timing>
+</p:sld>
+</file>
+
+<file path=ppt/slides/slide29.xml><?xml version="1.0" encoding="utf-8"?>
+<p:sld xmlns:a="http://schemas.openxmlformats.org/drawingml/2006/main" xmlns:r="http://schemas.openxmlformats.org/officeDocument/2006/relationships" xmlns:p="http://schemas.openxmlformats.org/presentationml/2006/main">
+  <p:cSld>
+    <p:spTree>
+      <p:nvGrpSpPr>
+        <p:cNvPr id="1" name=""/>
+        <p:cNvGrpSpPr/>
+        <p:nvPr/>
+      </p:nvGrpSpPr>
+      <p:grpSpPr>
+        <a:xfrm>
+          <a:off x="0" y="0"/>
+          <a:ext cx="0" cy="0"/>
+          <a:chOff x="0" y="0"/>
+          <a:chExt cx="0" cy="0"/>
+        </a:xfrm>
+      </p:grpSpPr>
+      <p:sp>
+        <p:nvSpPr>
+          <p:cNvPr id="2" name="Title 1"/>
+          <p:cNvSpPr>
+            <a:spLocks noGrp="1"/>
+          </p:cNvSpPr>
+          <p:nvPr>
+            <p:ph type="title"/>
+          </p:nvPr>
+        </p:nvSpPr>
+        <p:spPr/>
+        <p:txBody>
+          <a:bodyPr/>
+          <a:lstStyle/>
+          <a:p>
+            <a:endParaRPr lang="en-GB"/>
+          </a:p>
+        </p:txBody>
+      </p:sp>
+      <p:sp>
+        <p:nvSpPr>
+          <p:cNvPr id="3" name="Content Placeholder 2"/>
+          <p:cNvSpPr>
+            <a:spLocks noGrp="1"/>
+          </p:cNvSpPr>
+          <p:nvPr>
+            <p:ph idx="1"/>
+          </p:nvPr>
+        </p:nvSpPr>
+        <p:spPr/>
+        <p:txBody>
+          <a:bodyPr/>
+          <a:lstStyle/>
+          <a:p>
+            <a:endParaRPr lang="en-GB"/>
+          </a:p>
+        </p:txBody>
+      </p:sp>
+    </p:spTree>
+    <p:extLst>
+      <p:ext uri="{BB962C8B-B14F-4D97-AF65-F5344CB8AC3E}">
+        <p14:creationId xmlns:p14="http://schemas.microsoft.com/office/powerpoint/2010/main" val="1164828355"/>
+      </p:ext>
+    </p:extLst>
+  </p:cSld>
+  <p:clrMapOvr>
+    <a:masterClrMapping/>
+  </p:clrMapOvr>
+  <p:timing>
+    <p:tnLst>
+      <p:par>
+        <p:cTn id="1" dur="indefinite" restart="never" nodeType="tmRoot"/>
+      </p:par>
+    </p:tnLst>
+  </p:timing>
 </p:sld>
 </file>
 

</xml_diff>